<commit_message>
Update Sprint 4 presentation with revised content and visuals
</commit_message>
<xml_diff>
--- a/presentations/ResearchLens_AI_Sprint4_Update.pptx
+++ b/presentations/ResearchLens_AI_Sprint4_Update.pptx
@@ -683,7 +683,7 @@
           <a:p>
             <a:r>
               <a:rPr lang="en-US" dirty="0"/>
-              <a:t>Point out the two 'Not extracted yet' rows in the screenshot, then the Export dropdown.</a:t>
+              <a:t>Point out the two citation chips in the screenshot: one verified (green check), one not (amber question mark) — both render, neither is hidden.</a:t>
             </a:r>
             <a:endParaRPr lang="en-US" dirty="0"/>
           </a:p>
@@ -947,7 +947,7 @@
           <a:p>
             <a:r>
               <a:rPr lang="en-US" dirty="0"/>
-              <a:t>Closing slide: tech stack, the three decisions most likely to be probed, and the roadmap into Sprint 5.</a:t>
+              <a:t>Closing slide: the final sprint's plan, straight from the project's own roadmap — demo readiness, quality validation, then end-to-end testing and bug fixes.</a:t>
             </a:r>
             <a:endParaRPr lang="en-US" dirty="0"/>
           </a:p>
@@ -1510,7 +1510,7 @@
                 <a:ea typeface="Calibri" pitchFamily="34" charset="-122"/>
                 <a:cs typeface="Calibri" pitchFamily="34" charset="-120"/>
               </a:rPr>
-              <a:t>Literature Matrix   ·   Paper Synthesis   ·   Ask the Literature</a:t>
+              <a:t>Evidence Tracking   ·   Paper Synthesis   ·   Ask the Literature</a:t>
             </a:r>
             <a:endParaRPr lang="en-US" sz="1600" dirty="0"/>
           </a:p>
@@ -1926,7 +1926,7 @@
                 <a:ea typeface="Calibri" pitchFamily="34" charset="-122"/>
                 <a:cs typeface="Calibri" pitchFamily="34" charset="-120"/>
               </a:rPr>
-              <a:t>Compare papers side by side</a:t>
+              <a:t>Ground every AI answer in its source</a:t>
             </a:r>
             <a:endParaRPr lang="en-US" sz="1150" dirty="0"/>
           </a:p>
@@ -1965,7 +1965,7 @@
                 <a:ea typeface="Cambria" pitchFamily="34" charset="-122"/>
                 <a:cs typeface="Cambria" pitchFamily="34" charset="-120"/>
               </a:rPr>
-              <a:t>Literature Matrix</a:t>
+              <a:t>Evidence Tracking</a:t>
             </a:r>
             <a:endParaRPr lang="en-US" sz="1600" dirty="0"/>
           </a:p>
@@ -2004,7 +2004,7 @@
                 <a:ea typeface="Calibri" pitchFamily="34" charset="-122"/>
                 <a:cs typeface="Calibri" pitchFamily="34" charset="-120"/>
               </a:rPr>
-              <a:t>A structured, exportable table — Methodology / Sample / Findings / Limitations — across every saved paper.</a:t>
+              <a:t>Every AI answer links back to the exact paper and sentence it drew from, checked against that paper's own text — verified or not, never hidden.</a:t>
             </a:r>
             <a:endParaRPr lang="en-US" sz="1150" dirty="0"/>
           </a:p>
@@ -2573,7 +2573,7 @@
                 <a:ea typeface="Cambria" pitchFamily="34" charset="-122"/>
                 <a:cs typeface="Cambria" pitchFamily="34" charset="-120"/>
               </a:rPr>
-              <a:t>Literature Matrix</a:t>
+              <a:t>Evidence Tracking</a:t>
             </a:r>
             <a:endParaRPr lang="en-US" sz="2800" dirty="0"/>
           </a:p>
@@ -2612,7 +2612,7 @@
                 <a:ea typeface="Calibri" pitchFamily="34" charset="-122"/>
                 <a:cs typeface="Calibri" pitchFamily="34" charset="-120"/>
               </a:rPr>
-              <a:t>A structured, side-by-side comparison table across every saved paper</a:t>
+              <a:t>Every AI answer links back to the exact paper and sentence it drew from</a:t>
             </a:r>
             <a:endParaRPr lang="en-US" sz="1400" dirty="0"/>
           </a:p>
@@ -2620,7 +2620,7 @@
       </p:sp>
       <p:pic>
         <p:nvPicPr>
-          <p:cNvPr id="5" name="Image 0" descr="literature_matrix.png">    </p:cNvPr>
+          <p:cNvPr id="5" name="Image 0" descr="evidence_tracking.png">    </p:cNvPr>
           <p:cNvPicPr>
             <a:picLocks noChangeAspect="1"/>
           </p:cNvPicPr>
@@ -2635,7 +2635,7 @@
         <p:spPr>
           <a:xfrm>
             <a:off x="548640" y="1828800"/>
-            <a:ext cx="5074920" cy="4778644"/>
+            <a:ext cx="4572000" cy="4232672"/>
           </a:xfrm>
           <a:prstGeom prst="rect">
             <a:avLst/>
@@ -2657,8 +2657,8 @@
         </p:nvSpPr>
         <p:spPr>
           <a:xfrm>
-            <a:off x="6035040" y="1828800"/>
-            <a:ext cx="5605272" cy="1234440"/>
+            <a:off x="5532120" y="1828800"/>
+            <a:ext cx="6108192" cy="1234440"/>
           </a:xfrm>
           <a:prstGeom prst="roundRect">
             <a:avLst>
@@ -2691,8 +2691,8 @@
         </p:nvSpPr>
         <p:spPr>
           <a:xfrm>
-            <a:off x="6309360" y="1828800"/>
-            <a:ext cx="5056632" cy="1234440"/>
+            <a:off x="5806440" y="1828800"/>
+            <a:ext cx="5559552" cy="1234440"/>
           </a:xfrm>
           <a:prstGeom prst="rect">
             <a:avLst/>
@@ -2716,7 +2716,7 @@
                 <a:ea typeface="Calibri" pitchFamily="34" charset="-122"/>
                 <a:cs typeface="Calibri" pitchFamily="34" charset="-120"/>
               </a:rPr>
-              <a:t>One row per saved paper, four fixed columns — Methodology, Sample, Findings, Limitations. Fixing the columns keeps every row directly comparable, and the fields live on the paper itself, so they're shared the moment the same paper is saved to a second project.</a:t>
+              <a:t>AI Summary, Paper Synthesis, and Ask the Literature all cite their sources at the sentence level — not just “trust the AI.” Each citation is checked against the paper's own saved text before it's ever shown, turning a generated claim into something a researcher can actually verify.</a:t>
             </a:r>
             <a:endParaRPr lang="en-US" sz="1150" dirty="0"/>
           </a:p>
@@ -2730,8 +2730,8 @@
         </p:nvSpPr>
         <p:spPr>
           <a:xfrm>
-            <a:off x="6035040" y="3246120"/>
-            <a:ext cx="5605272" cy="320040"/>
+            <a:off x="5532120" y="3246120"/>
+            <a:ext cx="6108192" cy="320040"/>
           </a:xfrm>
           <a:prstGeom prst="rect">
             <a:avLst/>
@@ -2769,7 +2769,7 @@
         </p:nvSpPr>
         <p:spPr>
           <a:xfrm>
-            <a:off x="6035040" y="3657600"/>
+            <a:off x="5532120" y="3657600"/>
             <a:ext cx="329184" cy="329184"/>
           </a:xfrm>
           <a:prstGeom prst="ellipse">
@@ -2789,7 +2789,7 @@
         </p:nvSpPr>
         <p:spPr>
           <a:xfrm>
-            <a:off x="6035040" y="3639312"/>
+            <a:off x="5532120" y="3639312"/>
             <a:ext cx="329184" cy="329184"/>
           </a:xfrm>
           <a:prstGeom prst="rect">
@@ -2828,8 +2828,8 @@
         </p:nvSpPr>
         <p:spPr>
           <a:xfrm>
-            <a:off x="6492240" y="3621024"/>
-            <a:ext cx="5148072" cy="274320"/>
+            <a:off x="5989320" y="3621024"/>
+            <a:ext cx="5650992" cy="274320"/>
           </a:xfrm>
           <a:prstGeom prst="rect">
             <a:avLst/>
@@ -2853,7 +2853,7 @@
                 <a:ea typeface="Calibri" pitchFamily="34" charset="-122"/>
                 <a:cs typeface="Calibri" pitchFamily="34" charset="-120"/>
               </a:rPr>
-              <a:t>Extract with AI, one click</a:t>
+              <a:t>A trailing, machine-readable block</a:t>
             </a:r>
             <a:endParaRPr lang="en-US" sz="1200" dirty="0"/>
           </a:p>
@@ -2867,8 +2867,8 @@
         </p:nvSpPr>
         <p:spPr>
           <a:xfrm>
-            <a:off x="6492240" y="3895344"/>
-            <a:ext cx="5148072" cy="777240"/>
+            <a:off x="5989320" y="3895344"/>
+            <a:ext cx="5650992" cy="777240"/>
           </a:xfrm>
           <a:prstGeom prst="rect">
             <a:avLst/>
@@ -2892,7 +2892,7 @@
                 <a:ea typeface="Calibri" pitchFamily="34" charset="-122"/>
                 <a:cs typeface="Calibri" pitchFamily="34" charset="-120"/>
               </a:rPr>
-              <a:t>stream_extract_matrix_fields() asks for exactly four plain-prose paragraphs, split into the table's four cells.</a:t>
+              <a:t>The model appends a block naming exactly which paper (and quote) each part of its answer drew from, parsed out server-side before anything is shown or saved.</a:t>
             </a:r>
             <a:endParaRPr lang="en-US" sz="1050" dirty="0"/>
           </a:p>
@@ -2906,7 +2906,7 @@
         </p:nvSpPr>
         <p:spPr>
           <a:xfrm>
-            <a:off x="6035040" y="4681728"/>
+            <a:off x="5532120" y="4681728"/>
             <a:ext cx="329184" cy="329184"/>
           </a:xfrm>
           <a:prstGeom prst="ellipse">
@@ -2926,7 +2926,7 @@
         </p:nvSpPr>
         <p:spPr>
           <a:xfrm>
-            <a:off x="6035040" y="4663440"/>
+            <a:off x="5532120" y="4663440"/>
             <a:ext cx="329184" cy="329184"/>
           </a:xfrm>
           <a:prstGeom prst="rect">
@@ -2965,8 +2965,8 @@
         </p:nvSpPr>
         <p:spPr>
           <a:xfrm>
-            <a:off x="6492240" y="4645152"/>
-            <a:ext cx="5148072" cy="274320"/>
+            <a:off x="5989320" y="4645152"/>
+            <a:ext cx="5650992" cy="274320"/>
           </a:xfrm>
           <a:prstGeom prst="rect">
             <a:avLst/>
@@ -2990,7 +2990,7 @@
                 <a:ea typeface="Calibri" pitchFamily="34" charset="-122"/>
                 <a:cs typeface="Calibri" pitchFamily="34" charset="-120"/>
               </a:rPr>
-              <a:t>Edit by hand, any time</a:t>
+              <a:t>Checked against the real source text</a:t>
             </a:r>
             <a:endParaRPr lang="en-US" sz="1200" dirty="0"/>
           </a:p>
@@ -3004,8 +3004,8 @@
         </p:nvSpPr>
         <p:spPr>
           <a:xfrm>
-            <a:off x="6492240" y="4919472"/>
-            <a:ext cx="5148072" cy="777240"/>
+            <a:off x="5989320" y="4919472"/>
+            <a:ext cx="5650992" cy="777240"/>
           </a:xfrm>
           <a:prstGeom prst="rect">
             <a:avLst/>
@@ -3029,7 +3029,7 @@
                 <a:ea typeface="Calibri" pitchFamily="34" charset="-122"/>
                 <a:cs typeface="Calibri" pitchFamily="34" charset="-120"/>
               </a:rPr>
-              <a:t>Manual edits use the exact same save path as AI extraction — neither is treated as more authoritative.</a:t>
+              <a:t>Each quote is verified as an exact match against the paper's own abstract or extracted text — never invented, never assumed.</a:t>
             </a:r>
             <a:endParaRPr lang="en-US" sz="1050" dirty="0"/>
           </a:p>
@@ -3043,7 +3043,7 @@
         </p:nvSpPr>
         <p:spPr>
           <a:xfrm>
-            <a:off x="6035040" y="5705856"/>
+            <a:off x="5532120" y="5705856"/>
             <a:ext cx="329184" cy="329184"/>
           </a:xfrm>
           <a:prstGeom prst="ellipse">
@@ -3063,7 +3063,7 @@
         </p:nvSpPr>
         <p:spPr>
           <a:xfrm>
-            <a:off x="6035040" y="5687568"/>
+            <a:off x="5532120" y="5687568"/>
             <a:ext cx="329184" cy="329184"/>
           </a:xfrm>
           <a:prstGeom prst="rect">
@@ -3102,8 +3102,8 @@
         </p:nvSpPr>
         <p:spPr>
           <a:xfrm>
-            <a:off x="6492240" y="5669280"/>
-            <a:ext cx="5148072" cy="274320"/>
+            <a:off x="5989320" y="5669280"/>
+            <a:ext cx="5650992" cy="274320"/>
           </a:xfrm>
           <a:prstGeom prst="rect">
             <a:avLst/>
@@ -3127,7 +3127,7 @@
                 <a:ea typeface="Calibri" pitchFamily="34" charset="-122"/>
                 <a:cs typeface="Calibri" pitchFamily="34" charset="-120"/>
               </a:rPr>
-              <a:t>One export, three formats</a:t>
+              <a:t>Verified or not, never hidden</a:t>
             </a:r>
             <a:endParaRPr lang="en-US" sz="1200" dirty="0"/>
           </a:p>
@@ -3141,8 +3141,8 @@
         </p:nvSpPr>
         <p:spPr>
           <a:xfrm>
-            <a:off x="6492240" y="5943600"/>
-            <a:ext cx="5148072" cy="777240"/>
+            <a:off x="5989320" y="5943600"/>
+            <a:ext cx="5650992" cy="777240"/>
           </a:xfrm>
           <a:prstGeom prst="rect">
             <a:avLst/>
@@ -3166,7 +3166,7 @@
                 <a:ea typeface="Calibri" pitchFamily="34" charset="-122"/>
                 <a:cs typeface="Calibri" pitchFamily="34" charset="-120"/>
               </a:rPr>
-              <a:t>Excel (openpyxl), PDF (reportlab), and Word (python-docx) all read from one shared row-builder, so they can't drift apart.</a:t>
+              <a:t>An unverified quote still renders, just labeled differently — a paraphrase can legitimately fail an exact-match check without being wrong.</a:t>
             </a:r>
             <a:endParaRPr lang="en-US" sz="1050" dirty="0"/>
           </a:p>
@@ -4780,7 +4780,7 @@
                 <a:ea typeface="Calibri" pitchFamily="34" charset="-122"/>
                 <a:cs typeface="Calibri" pitchFamily="34" charset="-120"/>
               </a:rPr>
-              <a:t>UNDER THE HOOD · THOUGHT PROCESS · WHAT'S NEXT</a:t>
+              <a:t>WHAT'S NEXT</a:t>
             </a:r>
             <a:endParaRPr lang="en-US" sz="1250" dirty="0"/>
           </a:p>
@@ -4811,7 +4811,7 @@
               <a:buNone/>
             </a:pPr>
             <a:r>
-              <a:rPr lang="en-US" sz="2800" b="1" dirty="0">
+              <a:rPr lang="en-US" sz="2600" b="1" dirty="0">
                 <a:solidFill>
                   <a:srgbClr val="FFFFFF"/>
                 </a:solidFill>
@@ -4819,22 +4819,61 @@
                 <a:ea typeface="Cambria" pitchFamily="34" charset="-122"/>
                 <a:cs typeface="Cambria" pitchFamily="34" charset="-120"/>
               </a:rPr>
-              <a:t>Tech, decisions, and the road ahead</a:t>
-            </a:r>
-            <a:endParaRPr lang="en-US" sz="2800" dirty="0"/>
-          </a:p>
-        </p:txBody>
-      </p:sp>
-      <p:sp>
-        <p:nvSpPr>
-          <p:cNvPr id="5" name="Shape 3"/>
+              <a:t>Sprint 5 — Integration, Testing &amp; Final Prototype</a:t>
+            </a:r>
+            <a:endParaRPr lang="en-US" sz="2600" dirty="0"/>
+          </a:p>
+        </p:txBody>
+      </p:sp>
+      <p:sp>
+        <p:nvSpPr>
+          <p:cNvPr id="5" name="Text 3"/>
+          <p:cNvSpPr txBox="1"/>
+          <p:nvPr/>
+        </p:nvSpPr>
+        <p:spPr>
+          <a:xfrm>
+            <a:off x="548640" y="1371600"/>
+            <a:ext cx="10789920" cy="411480"/>
+          </a:xfrm>
+          <a:prstGeom prst="rect">
+            <a:avLst/>
+          </a:prstGeom>
+          <a:noFill/>
+          <a:ln/>
+        </p:spPr>
+        <p:txBody>
+          <a:bodyPr wrap="square" lIns="0" tIns="0" rIns="0" bIns="0" rtlCol="0" anchor="ctr"/>
+          <a:lstStyle/>
+          <a:p>
+            <a:pPr indent="0" marL="0">
+              <a:buNone/>
+            </a:pPr>
+            <a:r>
+              <a:rPr lang="en-US" sz="1400" i="1" dirty="0">
+                <a:solidFill>
+                  <a:srgbClr val="CADCFC"/>
+                </a:solidFill>
+                <a:latin typeface="Calibri" pitchFamily="34" charset="0"/>
+                <a:ea typeface="Calibri" pitchFamily="34" charset="-122"/>
+                <a:cs typeface="Calibri" pitchFamily="34" charset="-120"/>
+              </a:rPr>
+              <a:t>Turns the Sprint 3–4 features into one stable, demo-ready prototype and closes out the project.</a:t>
+            </a:r>
+            <a:endParaRPr lang="en-US" sz="1400" dirty="0"/>
+          </a:p>
+        </p:txBody>
+      </p:sp>
+      <p:sp>
+        <p:nvSpPr>
+          <p:cNvPr id="6" name="Shape 4"/>
           <p:cNvSpPr/>
           <p:nvPr/>
         </p:nvSpPr>
         <p:spPr>
           <a:xfrm>
-            <a:off x="548640" y="1783080"/>
-            <a:ext cx="3611880" cy="4206240"/>
+            <a:off x="548640" y="2057400"/>
+            <a:ext cx="3611880" cy="3931920"/>
           </a:xfrm>
           <a:prstGeom prst="roundRect">
             <a:avLst>
@@ -4854,53 +4893,112 @@
       </p:sp>
       <p:sp>
         <p:nvSpPr>
-          <p:cNvPr id="6" name="Text 4"/>
-          <p:cNvSpPr txBox="1"/>
-          <p:nvPr/>
-        </p:nvSpPr>
-        <p:spPr>
-          <a:xfrm>
-            <a:off x="804672" y="1984248"/>
-            <a:ext cx="3099816" cy="365760"/>
-          </a:xfrm>
-          <a:prstGeom prst="rect">
-            <a:avLst/>
-          </a:prstGeom>
-          <a:noFill/>
-          <a:ln/>
-        </p:spPr>
-        <p:txBody>
-          <a:bodyPr wrap="square" lIns="0" tIns="0" rIns="0" bIns="0" rtlCol="0" anchor="ctr"/>
-          <a:lstStyle/>
-          <a:p>
-            <a:pPr indent="0" marL="0">
-              <a:buNone/>
-            </a:pPr>
-            <a:r>
-              <a:rPr lang="en-US" sz="1500" b="1" dirty="0">
-                <a:solidFill>
-                  <a:srgbClr val="CADCFC"/>
+          <p:cNvPr id="7" name="Shape 5"/>
+          <p:cNvSpPr/>
+          <p:nvPr/>
+        </p:nvSpPr>
+        <p:spPr>
+          <a:xfrm>
+            <a:off x="804672" y="2295144"/>
+            <a:ext cx="384048" cy="384048"/>
+          </a:xfrm>
+          <a:prstGeom prst="ellipse">
+            <a:avLst/>
+          </a:prstGeom>
+          <a:solidFill>
+            <a:srgbClr val="6D5EF0"/>
+          </a:solidFill>
+          <a:ln/>
+        </p:spPr>
+      </p:sp>
+      <p:sp>
+        <p:nvSpPr>
+          <p:cNvPr id="8" name="Text 6"/>
+          <p:cNvSpPr txBox="1"/>
+          <p:nvPr/>
+        </p:nvSpPr>
+        <p:spPr>
+          <a:xfrm>
+            <a:off x="804672" y="2276856"/>
+            <a:ext cx="384048" cy="384048"/>
+          </a:xfrm>
+          <a:prstGeom prst="rect">
+            <a:avLst/>
+          </a:prstGeom>
+          <a:noFill/>
+          <a:ln/>
+        </p:spPr>
+        <p:txBody>
+          <a:bodyPr wrap="square" lIns="0" tIns="0" rIns="0" bIns="0" rtlCol="0" anchor="ctr"/>
+          <a:lstStyle/>
+          <a:p>
+            <a:pPr algn="ctr" indent="0" marL="0">
+              <a:buNone/>
+            </a:pPr>
+            <a:r>
+              <a:rPr lang="en-US" sz="1092" b="1" dirty="0">
+                <a:solidFill>
+                  <a:srgbClr val="FFFFFF"/>
                 </a:solidFill>
                 <a:latin typeface="Cambria" pitchFamily="34" charset="0"/>
                 <a:ea typeface="Cambria" pitchFamily="34" charset="-122"/>
                 <a:cs typeface="Cambria" pitchFamily="34" charset="-120"/>
               </a:rPr>
-              <a:t>Tech stack</a:t>
-            </a:r>
-            <a:endParaRPr lang="en-US" sz="1500" dirty="0"/>
-          </a:p>
-        </p:txBody>
-      </p:sp>
-      <p:sp>
-        <p:nvSpPr>
-          <p:cNvPr id="7" name="Text 5"/>
-          <p:cNvSpPr txBox="1"/>
-          <p:nvPr/>
-        </p:nvSpPr>
-        <p:spPr>
-          <a:xfrm>
-            <a:off x="804672" y="2441448"/>
-            <a:ext cx="3099816" cy="3337560"/>
+              <a:t>1</a:t>
+            </a:r>
+            <a:endParaRPr lang="en-US" sz="1092" dirty="0"/>
+          </a:p>
+        </p:txBody>
+      </p:sp>
+      <p:sp>
+        <p:nvSpPr>
+          <p:cNvPr id="9" name="Text 7"/>
+          <p:cNvSpPr txBox="1"/>
+          <p:nvPr/>
+        </p:nvSpPr>
+        <p:spPr>
+          <a:xfrm>
+            <a:off x="1335024" y="2240280"/>
+            <a:ext cx="2606040" cy="502920"/>
+          </a:xfrm>
+          <a:prstGeom prst="rect">
+            <a:avLst/>
+          </a:prstGeom>
+          <a:noFill/>
+          <a:ln/>
+        </p:spPr>
+        <p:txBody>
+          <a:bodyPr wrap="square" lIns="0" tIns="0" rIns="0" bIns="0" rtlCol="0" anchor="ctr"/>
+          <a:lstStyle/>
+          <a:p>
+            <a:pPr indent="0" marL="0">
+              <a:buNone/>
+            </a:pPr>
+            <a:r>
+              <a:rPr lang="en-US" sz="1450" b="1" dirty="0">
+                <a:solidFill>
+                  <a:srgbClr val="CADCFC"/>
+                </a:solidFill>
+                <a:latin typeface="Cambria" pitchFamily="34" charset="0"/>
+                <a:ea typeface="Cambria" pitchFamily="34" charset="-122"/>
+                <a:cs typeface="Cambria" pitchFamily="34" charset="-120"/>
+              </a:rPr>
+              <a:t>Get demo-ready</a:t>
+            </a:r>
+            <a:endParaRPr lang="en-US" sz="1450" dirty="0"/>
+          </a:p>
+        </p:txBody>
+      </p:sp>
+      <p:sp>
+        <p:nvSpPr>
+          <p:cNvPr id="10" name="Text 8"/>
+          <p:cNvSpPr txBox="1"/>
+          <p:nvPr/>
+        </p:nvSpPr>
+        <p:spPr>
+          <a:xfrm>
+            <a:off x="804672" y="2926080"/>
+            <a:ext cx="3099816" cy="2880360"/>
           </a:xfrm>
           <a:prstGeom prst="rect">
             <a:avLst/>
@@ -4914,13 +5012,13 @@
           <a:p>
             <a:pPr marL="342900" indent="-342900">
               <a:spcAft>
-                <a:spcPts val="900"/>
+                <a:spcPts val="1000"/>
               </a:spcAft>
               <a:buSzPct val="100000"/>
               <a:buChar char="•"/>
             </a:pPr>
             <a:r>
-              <a:rPr lang="en-US" sz="1050" dirty="0">
+              <a:rPr lang="en-US" sz="1100" dirty="0">
                 <a:solidFill>
                   <a:srgbClr val="FFFFFF"/>
                 </a:solidFill>
@@ -4928,85 +5026,22 @@
                 <a:ea typeface="Calibri" pitchFamily="34" charset="-122"/>
                 <a:cs typeface="Calibri" pitchFamily="34" charset="-120"/>
               </a:rPr>
-              <a:t>OpenAI Responses API, streamed token-by-token</a:t>
-            </a:r>
-            <a:endParaRPr lang="en-US" sz="1050" dirty="0"/>
-          </a:p>
-          <a:p>
-            <a:pPr marL="342900" indent="-342900">
-              <a:spcAft>
-                <a:spcPts val="900"/>
-              </a:spcAft>
-              <a:buSzPct val="100000"/>
-              <a:buChar char="•"/>
-            </a:pPr>
-            <a:r>
-              <a:rPr lang="en-US" sz="1050" dirty="0">
-                <a:solidFill>
-                  <a:srgbClr val="FFFFFF"/>
-                </a:solidFill>
-                <a:latin typeface="Calibri" pitchFamily="34" charset="0"/>
-                <a:ea typeface="Calibri" pitchFamily="34" charset="-122"/>
-                <a:cs typeface="Calibri" pitchFamily="34" charset="-120"/>
-              </a:rPr>
-              <a:t>SQLAlchemy + the app's existing lightweight migration helper (no new framework)</a:t>
-            </a:r>
-            <a:endParaRPr lang="en-US" sz="1050" dirty="0"/>
-          </a:p>
-          <a:p>
-            <a:pPr marL="342900" indent="-342900">
-              <a:spcAft>
-                <a:spcPts val="900"/>
-              </a:spcAft>
-              <a:buSzPct val="100000"/>
-              <a:buChar char="•"/>
-            </a:pPr>
-            <a:r>
-              <a:rPr lang="en-US" sz="1050" dirty="0">
-                <a:solidFill>
-                  <a:srgbClr val="FFFFFF"/>
-                </a:solidFill>
-                <a:latin typeface="Calibri" pitchFamily="34" charset="0"/>
-                <a:ea typeface="Calibri" pitchFamily="34" charset="-122"/>
-                <a:cs typeface="Calibri" pitchFamily="34" charset="-120"/>
-              </a:rPr>
-              <a:t>openpyxl · reportlab · python-docx, one shared row-builder</a:t>
-            </a:r>
-            <a:endParaRPr lang="en-US" sz="1050" dirty="0"/>
-          </a:p>
-          <a:p>
-            <a:pPr marL="342900" indent="-342900">
-              <a:spcAft>
-                <a:spcPts val="900"/>
-              </a:spcAft>
-              <a:buSzPct val="100000"/>
-              <a:buChar char="•"/>
-            </a:pPr>
-            <a:r>
-              <a:rPr lang="en-US" sz="1050" dirty="0">
-                <a:solidFill>
-                  <a:srgbClr val="FFFFFF"/>
-                </a:solidFill>
-                <a:latin typeface="Calibri" pitchFamily="34" charset="0"/>
-                <a:ea typeface="Calibri" pitchFamily="34" charset="-122"/>
-                <a:cs typeface="Calibri" pitchFamily="34" charset="-120"/>
-              </a:rPr>
-              <a:t>NDJSON over fetch(), one generic streaming handler reused by every feature</a:t>
-            </a:r>
-            <a:endParaRPr lang="en-US" sz="1050" dirty="0"/>
-          </a:p>
-        </p:txBody>
-      </p:sp>
-      <p:sp>
-        <p:nvSpPr>
-          <p:cNvPr id="8" name="Shape 6"/>
+              <a:t>Prepare Demo Mode — a small, prepared local dataset and an offline-safe path for the live presentation</a:t>
+            </a:r>
+            <a:endParaRPr lang="en-US" sz="1100" dirty="0"/>
+          </a:p>
+        </p:txBody>
+      </p:sp>
+      <p:sp>
+        <p:nvSpPr>
+          <p:cNvPr id="11" name="Shape 9"/>
           <p:cNvSpPr/>
           <p:nvPr/>
         </p:nvSpPr>
         <p:spPr>
           <a:xfrm>
-            <a:off x="4343400" y="1783080"/>
-            <a:ext cx="3611880" cy="4206240"/>
+            <a:off x="4343400" y="2057400"/>
+            <a:ext cx="3611880" cy="3931920"/>
           </a:xfrm>
           <a:prstGeom prst="roundRect">
             <a:avLst>
@@ -5026,53 +5061,112 @@
       </p:sp>
       <p:sp>
         <p:nvSpPr>
-          <p:cNvPr id="9" name="Text 7"/>
-          <p:cNvSpPr txBox="1"/>
-          <p:nvPr/>
-        </p:nvSpPr>
-        <p:spPr>
-          <a:xfrm>
-            <a:off x="4599432" y="1984248"/>
-            <a:ext cx="3099816" cy="365760"/>
-          </a:xfrm>
-          <a:prstGeom prst="rect">
-            <a:avLst/>
-          </a:prstGeom>
-          <a:noFill/>
-          <a:ln/>
-        </p:spPr>
-        <p:txBody>
-          <a:bodyPr wrap="square" lIns="0" tIns="0" rIns="0" bIns="0" rtlCol="0" anchor="ctr"/>
-          <a:lstStyle/>
-          <a:p>
-            <a:pPr indent="0" marL="0">
-              <a:buNone/>
-            </a:pPr>
-            <a:r>
-              <a:rPr lang="en-US" sz="1500" b="1" dirty="0">
-                <a:solidFill>
-                  <a:srgbClr val="CADCFC"/>
+          <p:cNvPr id="12" name="Shape 10"/>
+          <p:cNvSpPr/>
+          <p:nvPr/>
+        </p:nvSpPr>
+        <p:spPr>
+          <a:xfrm>
+            <a:off x="4599432" y="2295144"/>
+            <a:ext cx="384048" cy="384048"/>
+          </a:xfrm>
+          <a:prstGeom prst="ellipse">
+            <a:avLst/>
+          </a:prstGeom>
+          <a:solidFill>
+            <a:srgbClr val="6D5EF0"/>
+          </a:solidFill>
+          <a:ln/>
+        </p:spPr>
+      </p:sp>
+      <p:sp>
+        <p:nvSpPr>
+          <p:cNvPr id="13" name="Text 11"/>
+          <p:cNvSpPr txBox="1"/>
+          <p:nvPr/>
+        </p:nvSpPr>
+        <p:spPr>
+          <a:xfrm>
+            <a:off x="4599432" y="2276856"/>
+            <a:ext cx="384048" cy="384048"/>
+          </a:xfrm>
+          <a:prstGeom prst="rect">
+            <a:avLst/>
+          </a:prstGeom>
+          <a:noFill/>
+          <a:ln/>
+        </p:spPr>
+        <p:txBody>
+          <a:bodyPr wrap="square" lIns="0" tIns="0" rIns="0" bIns="0" rtlCol="0" anchor="ctr"/>
+          <a:lstStyle/>
+          <a:p>
+            <a:pPr algn="ctr" indent="0" marL="0">
+              <a:buNone/>
+            </a:pPr>
+            <a:r>
+              <a:rPr lang="en-US" sz="1092" b="1" dirty="0">
+                <a:solidFill>
+                  <a:srgbClr val="FFFFFF"/>
                 </a:solidFill>
                 <a:latin typeface="Cambria" pitchFamily="34" charset="0"/>
                 <a:ea typeface="Cambria" pitchFamily="34" charset="-122"/>
                 <a:cs typeface="Cambria" pitchFamily="34" charset="-120"/>
               </a:rPr>
-              <a:t>Design decisions</a:t>
-            </a:r>
-            <a:endParaRPr lang="en-US" sz="1500" dirty="0"/>
-          </a:p>
-        </p:txBody>
-      </p:sp>
-      <p:sp>
-        <p:nvSpPr>
-          <p:cNvPr id="10" name="Text 8"/>
-          <p:cNvSpPr txBox="1"/>
-          <p:nvPr/>
-        </p:nvSpPr>
-        <p:spPr>
-          <a:xfrm>
-            <a:off x="4599432" y="2441448"/>
-            <a:ext cx="3099816" cy="3337560"/>
+              <a:t>2</a:t>
+            </a:r>
+            <a:endParaRPr lang="en-US" sz="1092" dirty="0"/>
+          </a:p>
+        </p:txBody>
+      </p:sp>
+      <p:sp>
+        <p:nvSpPr>
+          <p:cNvPr id="14" name="Text 12"/>
+          <p:cNvSpPr txBox="1"/>
+          <p:nvPr/>
+        </p:nvSpPr>
+        <p:spPr>
+          <a:xfrm>
+            <a:off x="5129784" y="2240280"/>
+            <a:ext cx="2606040" cy="502920"/>
+          </a:xfrm>
+          <a:prstGeom prst="rect">
+            <a:avLst/>
+          </a:prstGeom>
+          <a:noFill/>
+          <a:ln/>
+        </p:spPr>
+        <p:txBody>
+          <a:bodyPr wrap="square" lIns="0" tIns="0" rIns="0" bIns="0" rtlCol="0" anchor="ctr"/>
+          <a:lstStyle/>
+          <a:p>
+            <a:pPr indent="0" marL="0">
+              <a:buNone/>
+            </a:pPr>
+            <a:r>
+              <a:rPr lang="en-US" sz="1450" b="1" dirty="0">
+                <a:solidFill>
+                  <a:srgbClr val="CADCFC"/>
+                </a:solidFill>
+                <a:latin typeface="Cambria" pitchFamily="34" charset="0"/>
+                <a:ea typeface="Cambria" pitchFamily="34" charset="-122"/>
+                <a:cs typeface="Cambria" pitchFamily="34" charset="-120"/>
+              </a:rPr>
+              <a:t>Validate quality</a:t>
+            </a:r>
+            <a:endParaRPr lang="en-US" sz="1450" dirty="0"/>
+          </a:p>
+        </p:txBody>
+      </p:sp>
+      <p:sp>
+        <p:nvSpPr>
+          <p:cNvPr id="15" name="Text 13"/>
+          <p:cNvSpPr txBox="1"/>
+          <p:nvPr/>
+        </p:nvSpPr>
+        <p:spPr>
+          <a:xfrm>
+            <a:off x="4599432" y="2926080"/>
+            <a:ext cx="3099816" cy="2880360"/>
           </a:xfrm>
           <a:prstGeom prst="rect">
             <a:avLst/>
@@ -5086,13 +5180,13 @@
           <a:p>
             <a:pPr marL="342900" indent="-342900">
               <a:spcAft>
-                <a:spcPts val="900"/>
+                <a:spcPts val="1000"/>
               </a:spcAft>
               <a:buSzPct val="100000"/>
               <a:buChar char="•"/>
             </a:pPr>
             <a:r>
-              <a:rPr lang="en-US" sz="1050" dirty="0">
+              <a:rPr lang="en-US" sz="1100" dirty="0">
                 <a:solidFill>
                   <a:srgbClr val="FFFFFF"/>
                 </a:solidFill>
@@ -5100,20 +5194,20 @@
                 <a:ea typeface="Calibri" pitchFamily="34" charset="-122"/>
                 <a:cs typeface="Calibri" pitchFamily="34" charset="-120"/>
               </a:rPr>
-              <a:t>Matrix fields live on Paper, not per-project — a paper's methodology doesn't change by project</a:t>
-            </a:r>
-            <a:endParaRPr lang="en-US" sz="1050" dirty="0"/>
+              <a:t>Usability testing — structured testing with a small group of peers across the full workflow</a:t>
+            </a:r>
+            <a:endParaRPr lang="en-US" sz="1100" dirty="0"/>
           </a:p>
           <a:p>
             <a:pPr marL="342900" indent="-342900">
               <a:spcAft>
-                <a:spcPts val="900"/>
+                <a:spcPts val="1000"/>
               </a:spcAft>
               <a:buSzPct val="100000"/>
               <a:buChar char="•"/>
             </a:pPr>
             <a:r>
-              <a:rPr lang="en-US" sz="1050" dirty="0">
+              <a:rPr lang="en-US" sz="1100" dirty="0">
                 <a:solidFill>
                   <a:srgbClr val="FFFFFF"/>
                 </a:solidFill>
@@ -5121,43 +5215,22 @@
                 <a:ea typeface="Calibri" pitchFamily="34" charset="-122"/>
                 <a:cs typeface="Calibri" pitchFamily="34" charset="-120"/>
               </a:rPr>
-              <a:t>Synthesis hard-requires 2+ papers — an explicit guard beats a result that quietly reads wrong</a:t>
-            </a:r>
-            <a:endParaRPr lang="en-US" sz="1050" dirty="0"/>
-          </a:p>
-          <a:p>
-            <a:pPr marL="342900" indent="-342900">
-              <a:spcAft>
-                <a:spcPts val="900"/>
-              </a:spcAft>
-              <a:buSzPct val="100000"/>
-              <a:buChar char="•"/>
-            </a:pPr>
-            <a:r>
-              <a:rPr lang="en-US" sz="1050" dirty="0">
-                <a:solidFill>
-                  <a:srgbClr val="FFFFFF"/>
-                </a:solidFill>
-                <a:latin typeface="Calibri" pitchFamily="34" charset="0"/>
-                <a:ea typeface="Calibri" pitchFamily="34" charset="-122"/>
-                <a:cs typeface="Calibri" pitchFamily="34" charset="-120"/>
-              </a:rPr>
-              <a:t>One linear chat thread — an edited question truncates forward rather than branching</a:t>
-            </a:r>
-            <a:endParaRPr lang="en-US" sz="1050" dirty="0"/>
-          </a:p>
-        </p:txBody>
-      </p:sp>
-      <p:sp>
-        <p:nvSpPr>
-          <p:cNvPr id="11" name="Shape 9"/>
+              <a:t>AI accuracy testing — spot-check AI summaries, relevance analysis, and Ask the Literature answers against the source papers</a:t>
+            </a:r>
+            <a:endParaRPr lang="en-US" sz="1100" dirty="0"/>
+          </a:p>
+        </p:txBody>
+      </p:sp>
+      <p:sp>
+        <p:nvSpPr>
+          <p:cNvPr id="16" name="Shape 14"/>
           <p:cNvSpPr/>
           <p:nvPr/>
         </p:nvSpPr>
         <p:spPr>
           <a:xfrm>
-            <a:off x="8138160" y="1783080"/>
-            <a:ext cx="3611880" cy="4206240"/>
+            <a:off x="8138160" y="2057400"/>
+            <a:ext cx="3611880" cy="3931920"/>
           </a:xfrm>
           <a:prstGeom prst="roundRect">
             <a:avLst>
@@ -5177,53 +5250,112 @@
       </p:sp>
       <p:sp>
         <p:nvSpPr>
-          <p:cNvPr id="12" name="Text 10"/>
-          <p:cNvSpPr txBox="1"/>
-          <p:nvPr/>
-        </p:nvSpPr>
-        <p:spPr>
-          <a:xfrm>
-            <a:off x="8394192" y="1984248"/>
-            <a:ext cx="3099816" cy="365760"/>
-          </a:xfrm>
-          <a:prstGeom prst="rect">
-            <a:avLst/>
-          </a:prstGeom>
-          <a:noFill/>
-          <a:ln/>
-        </p:spPr>
-        <p:txBody>
-          <a:bodyPr wrap="square" lIns="0" tIns="0" rIns="0" bIns="0" rtlCol="0" anchor="ctr"/>
-          <a:lstStyle/>
-          <a:p>
-            <a:pPr indent="0" marL="0">
-              <a:buNone/>
-            </a:pPr>
-            <a:r>
-              <a:rPr lang="en-US" sz="1500" b="1" dirty="0">
-                <a:solidFill>
-                  <a:srgbClr val="CADCFC"/>
+          <p:cNvPr id="17" name="Shape 15"/>
+          <p:cNvSpPr/>
+          <p:nvPr/>
+        </p:nvSpPr>
+        <p:spPr>
+          <a:xfrm>
+            <a:off x="8394192" y="2295144"/>
+            <a:ext cx="384048" cy="384048"/>
+          </a:xfrm>
+          <a:prstGeom prst="ellipse">
+            <a:avLst/>
+          </a:prstGeom>
+          <a:solidFill>
+            <a:srgbClr val="6D5EF0"/>
+          </a:solidFill>
+          <a:ln/>
+        </p:spPr>
+      </p:sp>
+      <p:sp>
+        <p:nvSpPr>
+          <p:cNvPr id="18" name="Text 16"/>
+          <p:cNvSpPr txBox="1"/>
+          <p:nvPr/>
+        </p:nvSpPr>
+        <p:spPr>
+          <a:xfrm>
+            <a:off x="8394192" y="2276856"/>
+            <a:ext cx="384048" cy="384048"/>
+          </a:xfrm>
+          <a:prstGeom prst="rect">
+            <a:avLst/>
+          </a:prstGeom>
+          <a:noFill/>
+          <a:ln/>
+        </p:spPr>
+        <p:txBody>
+          <a:bodyPr wrap="square" lIns="0" tIns="0" rIns="0" bIns="0" rtlCol="0" anchor="ctr"/>
+          <a:lstStyle/>
+          <a:p>
+            <a:pPr algn="ctr" indent="0" marL="0">
+              <a:buNone/>
+            </a:pPr>
+            <a:r>
+              <a:rPr lang="en-US" sz="1092" b="1" dirty="0">
+                <a:solidFill>
+                  <a:srgbClr val="FFFFFF"/>
                 </a:solidFill>
                 <a:latin typeface="Cambria" pitchFamily="34" charset="0"/>
                 <a:ea typeface="Cambria" pitchFamily="34" charset="-122"/>
                 <a:cs typeface="Cambria" pitchFamily="34" charset="-120"/>
               </a:rPr>
-              <a:t>What's next</a:t>
-            </a:r>
-            <a:endParaRPr lang="en-US" sz="1500" dirty="0"/>
-          </a:p>
-        </p:txBody>
-      </p:sp>
-      <p:sp>
-        <p:nvSpPr>
-          <p:cNvPr id="13" name="Text 11"/>
-          <p:cNvSpPr txBox="1"/>
-          <p:nvPr/>
-        </p:nvSpPr>
-        <p:spPr>
-          <a:xfrm>
-            <a:off x="8394192" y="2441448"/>
-            <a:ext cx="3099816" cy="3337560"/>
+              <a:t>3</a:t>
+            </a:r>
+            <a:endParaRPr lang="en-US" sz="1092" dirty="0"/>
+          </a:p>
+        </p:txBody>
+      </p:sp>
+      <p:sp>
+        <p:nvSpPr>
+          <p:cNvPr id="19" name="Text 17"/>
+          <p:cNvSpPr txBox="1"/>
+          <p:nvPr/>
+        </p:nvSpPr>
+        <p:spPr>
+          <a:xfrm>
+            <a:off x="8924544" y="2240280"/>
+            <a:ext cx="2606040" cy="502920"/>
+          </a:xfrm>
+          <a:prstGeom prst="rect">
+            <a:avLst/>
+          </a:prstGeom>
+          <a:noFill/>
+          <a:ln/>
+        </p:spPr>
+        <p:txBody>
+          <a:bodyPr wrap="square" lIns="0" tIns="0" rIns="0" bIns="0" rtlCol="0" anchor="ctr"/>
+          <a:lstStyle/>
+          <a:p>
+            <a:pPr indent="0" marL="0">
+              <a:buNone/>
+            </a:pPr>
+            <a:r>
+              <a:rPr lang="en-US" sz="1450" b="1" dirty="0">
+                <a:solidFill>
+                  <a:srgbClr val="CADCFC"/>
+                </a:solidFill>
+                <a:latin typeface="Cambria" pitchFamily="34" charset="0"/>
+                <a:ea typeface="Cambria" pitchFamily="34" charset="-122"/>
+                <a:cs typeface="Cambria" pitchFamily="34" charset="-120"/>
+              </a:rPr>
+              <a:t>Test end to end, then fix</a:t>
+            </a:r>
+            <a:endParaRPr lang="en-US" sz="1450" dirty="0"/>
+          </a:p>
+        </p:txBody>
+      </p:sp>
+      <p:sp>
+        <p:nvSpPr>
+          <p:cNvPr id="20" name="Text 18"/>
+          <p:cNvSpPr txBox="1"/>
+          <p:nvPr/>
+        </p:nvSpPr>
+        <p:spPr>
+          <a:xfrm>
+            <a:off x="8394192" y="2926080"/>
+            <a:ext cx="3099816" cy="2880360"/>
           </a:xfrm>
           <a:prstGeom prst="rect">
             <a:avLst/>
@@ -5237,13 +5369,13 @@
           <a:p>
             <a:pPr marL="342900" indent="-342900">
               <a:spcAft>
-                <a:spcPts val="900"/>
+                <a:spcPts val="1000"/>
               </a:spcAft>
               <a:buSzPct val="100000"/>
               <a:buChar char="•"/>
             </a:pPr>
             <a:r>
-              <a:rPr lang="en-US" sz="1050" dirty="0">
+              <a:rPr lang="en-US" sz="1100" dirty="0">
                 <a:solidFill>
                   <a:srgbClr val="FFFFFF"/>
                 </a:solidFill>
@@ -5251,20 +5383,20 @@
                 <a:ea typeface="Calibri" pitchFamily="34" charset="-122"/>
                 <a:cs typeface="Calibri" pitchFamily="34" charset="-120"/>
               </a:rPr>
-              <a:t>Sprint 5 (underway): evidence tracking — citing the exact sentence each AI claim came from</a:t>
-            </a:r>
-            <a:endParaRPr lang="en-US" sz="1050" dirty="0"/>
+              <a:t>Test authentication, academic search, and AI analysis — including the OpenAI Agent — end to end</a:t>
+            </a:r>
+            <a:endParaRPr lang="en-US" sz="1100" dirty="0"/>
           </a:p>
           <a:p>
             <a:pPr marL="342900" indent="-342900">
               <a:spcAft>
-                <a:spcPts val="900"/>
+                <a:spcPts val="1000"/>
               </a:spcAft>
               <a:buSzPct val="100000"/>
               <a:buChar char="•"/>
             </a:pPr>
             <a:r>
-              <a:rPr lang="en-US" sz="1050" dirty="0">
+              <a:rPr lang="en-US" sz="1100" dirty="0">
                 <a:solidFill>
                   <a:srgbClr val="FFFFFF"/>
                 </a:solidFill>
@@ -5272,36 +5404,15 @@
                 <a:ea typeface="Calibri" pitchFamily="34" charset="-122"/>
                 <a:cs typeface="Calibri" pitchFamily="34" charset="-120"/>
               </a:rPr>
-              <a:t>A minimal tool-using OpenAI Agent, beyond today's prompt-and-stream pattern</a:t>
-            </a:r>
-            <a:endParaRPr lang="en-US" sz="1050" dirty="0"/>
-          </a:p>
-          <a:p>
-            <a:pPr marL="342900" indent="-342900">
-              <a:spcAft>
-                <a:spcPts val="900"/>
-              </a:spcAft>
-              <a:buSzPct val="100000"/>
-              <a:buChar char="•"/>
-            </a:pPr>
-            <a:r>
-              <a:rPr lang="en-US" sz="1050" dirty="0">
-                <a:solidFill>
-                  <a:srgbClr val="FFFFFF"/>
-                </a:solidFill>
-                <a:latin typeface="Calibri" pitchFamily="34" charset="0"/>
-                <a:ea typeface="Calibri" pitchFamily="34" charset="-122"/>
-                <a:cs typeface="Calibri" pitchFamily="34" charset="-120"/>
-              </a:rPr>
-              <a:t>A broader usability and AI-accuracy testing pass</a:t>
-            </a:r>
-            <a:endParaRPr lang="en-US" sz="1050" dirty="0"/>
-          </a:p>
-        </p:txBody>
-      </p:sp>
-      <p:sp>
-        <p:nvSpPr>
-          <p:cNvPr id="14" name="Text 12"/>
+              <a:t>Fix bugs found during the testing above</a:t>
+            </a:r>
+            <a:endParaRPr lang="en-US" sz="1100" dirty="0"/>
+          </a:p>
+        </p:txBody>
+      </p:sp>
+      <p:sp>
+        <p:nvSpPr>
+          <p:cNvPr id="21" name="Text 19"/>
           <p:cNvSpPr txBox="1"/>
           <p:nvPr/>
         </p:nvSpPr>
@@ -5340,7 +5451,7 @@
       </p:sp>
       <p:sp>
         <p:nvSpPr>
-          <p:cNvPr id="15" name="Text 13"/>
+          <p:cNvPr id="22" name="Text 20"/>
           <p:cNvSpPr txBox="1"/>
           <p:nvPr/>
         </p:nvSpPr>

</xml_diff>

<commit_message>
Update Sprint 4 presentation with latest revisions and enhancements
</commit_message>
<xml_diff>
--- a/presentations/ResearchLens_AI_Sprint4_Update.pptx
+++ b/presentations/ResearchLens_AI_Sprint4_Update.pptx
@@ -2845,7 +2845,7 @@
               <a:buNone/>
             </a:pPr>
             <a:r>
-              <a:rPr lang="en-US" sz="1200" b="1" dirty="0">
+              <a:rPr lang="en-US" sz="1300" b="1" dirty="0">
                 <a:solidFill>
                   <a:srgbClr val="1E1B4B"/>
                 </a:solidFill>
@@ -2853,9 +2853,9 @@
                 <a:ea typeface="Calibri" pitchFamily="34" charset="-122"/>
                 <a:cs typeface="Calibri" pitchFamily="34" charset="-120"/>
               </a:rPr>
-              <a:t>A trailing, machine-readable block</a:t>
-            </a:r>
-            <a:endParaRPr lang="en-US" sz="1200" dirty="0"/>
+              <a:t>Every answer comes with a receipt</a:t>
+            </a:r>
+            <a:endParaRPr lang="en-US" sz="1300" dirty="0"/>
           </a:p>
         </p:txBody>
       </p:sp>
@@ -2867,8 +2867,8 @@
         </p:nvSpPr>
         <p:spPr>
           <a:xfrm>
-            <a:off x="5989320" y="3895344"/>
-            <a:ext cx="5650992" cy="777240"/>
+            <a:off x="5989320" y="3931920"/>
+            <a:ext cx="5650992" cy="685800"/>
           </a:xfrm>
           <a:prstGeom prst="rect">
             <a:avLst/>
@@ -2884,7 +2884,7 @@
               <a:buNone/>
             </a:pPr>
             <a:r>
-              <a:rPr lang="en-US" sz="1050" dirty="0">
+              <a:rPr lang="en-US" sz="1150" dirty="0">
                 <a:solidFill>
                   <a:srgbClr val="6B7280"/>
                 </a:solidFill>
@@ -2892,9 +2892,9 @@
                 <a:ea typeface="Calibri" pitchFamily="34" charset="-122"/>
                 <a:cs typeface="Calibri" pitchFamily="34" charset="-120"/>
               </a:rPr>
-              <a:t>The model appends a block naming exactly which paper (and quote) each part of its answer drew from, parsed out server-side before anything is shown or saved.</a:t>
-            </a:r>
-            <a:endParaRPr lang="en-US" sz="1050" dirty="0"/>
+              <a:t>The AI doesn't just give an answer — it also says which paper, and which exact sentence, it got that answer from.</a:t>
+            </a:r>
+            <a:endParaRPr lang="en-US" sz="1150" dirty="0"/>
           </a:p>
         </p:txBody>
       </p:sp>
@@ -2982,7 +2982,7 @@
               <a:buNone/>
             </a:pPr>
             <a:r>
-              <a:rPr lang="en-US" sz="1200" b="1" dirty="0">
+              <a:rPr lang="en-US" sz="1300" b="1" dirty="0">
                 <a:solidFill>
                   <a:srgbClr val="1E1B4B"/>
                 </a:solidFill>
@@ -2990,9 +2990,9 @@
                 <a:ea typeface="Calibri" pitchFamily="34" charset="-122"/>
                 <a:cs typeface="Calibri" pitchFamily="34" charset="-120"/>
               </a:rPr>
-              <a:t>Checked against the real source text</a:t>
-            </a:r>
-            <a:endParaRPr lang="en-US" sz="1200" dirty="0"/>
+              <a:t>We check the quote is real</a:t>
+            </a:r>
+            <a:endParaRPr lang="en-US" sz="1300" dirty="0"/>
           </a:p>
         </p:txBody>
       </p:sp>
@@ -3004,8 +3004,8 @@
         </p:nvSpPr>
         <p:spPr>
           <a:xfrm>
-            <a:off x="5989320" y="4919472"/>
-            <a:ext cx="5650992" cy="777240"/>
+            <a:off x="5989320" y="4956048"/>
+            <a:ext cx="5650992" cy="685800"/>
           </a:xfrm>
           <a:prstGeom prst="rect">
             <a:avLst/>
@@ -3021,7 +3021,7 @@
               <a:buNone/>
             </a:pPr>
             <a:r>
-              <a:rPr lang="en-US" sz="1050" dirty="0">
+              <a:rPr lang="en-US" sz="1150" dirty="0">
                 <a:solidFill>
                   <a:srgbClr val="6B7280"/>
                 </a:solidFill>
@@ -3029,9 +3029,9 @@
                 <a:ea typeface="Calibri" pitchFamily="34" charset="-122"/>
                 <a:cs typeface="Calibri" pitchFamily="34" charset="-120"/>
               </a:rPr>
-              <a:t>Each quote is verified as an exact match against the paper's own abstract or extracted text — never invented, never assumed.</a:t>
-            </a:r>
-            <a:endParaRPr lang="en-US" sz="1050" dirty="0"/>
+              <a:t>The app automatically compares that sentence against the actual paper, to make sure it's really there.</a:t>
+            </a:r>
+            <a:endParaRPr lang="en-US" sz="1150" dirty="0"/>
           </a:p>
         </p:txBody>
       </p:sp>
@@ -3119,7 +3119,7 @@
               <a:buNone/>
             </a:pPr>
             <a:r>
-              <a:rPr lang="en-US" sz="1200" b="1" dirty="0">
+              <a:rPr lang="en-US" sz="1300" b="1" dirty="0">
                 <a:solidFill>
                   <a:srgbClr val="1E1B4B"/>
                 </a:solidFill>
@@ -3127,9 +3127,9 @@
                 <a:ea typeface="Calibri" pitchFamily="34" charset="-122"/>
                 <a:cs typeface="Calibri" pitchFamily="34" charset="-120"/>
               </a:rPr>
-              <a:t>Verified or not, never hidden</a:t>
-            </a:r>
-            <a:endParaRPr lang="en-US" sz="1200" dirty="0"/>
+              <a:t>Shown either way, clearly labeled</a:t>
+            </a:r>
+            <a:endParaRPr lang="en-US" sz="1300" dirty="0"/>
           </a:p>
         </p:txBody>
       </p:sp>
@@ -3141,8 +3141,8 @@
         </p:nvSpPr>
         <p:spPr>
           <a:xfrm>
-            <a:off x="5989320" y="5943600"/>
-            <a:ext cx="5650992" cy="777240"/>
+            <a:off x="5989320" y="5980176"/>
+            <a:ext cx="5650992" cy="685800"/>
           </a:xfrm>
           <a:prstGeom prst="rect">
             <a:avLst/>
@@ -3158,7 +3158,7 @@
               <a:buNone/>
             </a:pPr>
             <a:r>
-              <a:rPr lang="en-US" sz="1050" dirty="0">
+              <a:rPr lang="en-US" sz="1150" dirty="0">
                 <a:solidFill>
                   <a:srgbClr val="6B7280"/>
                 </a:solidFill>
@@ -3166,9 +3166,9 @@
                 <a:ea typeface="Calibri" pitchFamily="34" charset="-122"/>
                 <a:cs typeface="Calibri" pitchFamily="34" charset="-120"/>
               </a:rPr>
-              <a:t>An unverified quote still renders, just labeled differently — a paraphrase can legitimately fail an exact-match check without being wrong.</a:t>
-            </a:r>
-            <a:endParaRPr lang="en-US" sz="1050" dirty="0"/>
+              <a:t>If the quote checks out, it's marked verified. If not, it's still shown — just flagged — so nothing is hidden.</a:t>
+            </a:r>
+            <a:endParaRPr lang="en-US" sz="1150" dirty="0"/>
           </a:p>
         </p:txBody>
       </p:sp>
@@ -3587,7 +3587,7 @@
               <a:buNone/>
             </a:pPr>
             <a:r>
-              <a:rPr lang="en-US" sz="1200" b="1" dirty="0">
+              <a:rPr lang="en-US" sz="1300" b="1" dirty="0">
                 <a:solidFill>
                   <a:srgbClr val="1E1B4B"/>
                 </a:solidFill>
@@ -3595,9 +3595,9 @@
                 <a:ea typeface="Calibri" pitchFamily="34" charset="-122"/>
                 <a:cs typeface="Calibri" pitchFamily="34" charset="-120"/>
               </a:rPr>
-              <a:t>Capsule per paper</a:t>
-            </a:r>
-            <a:endParaRPr lang="en-US" sz="1200" dirty="0"/>
+              <a:t>Pick a few papers</a:t>
+            </a:r>
+            <a:endParaRPr lang="en-US" sz="1300" dirty="0"/>
           </a:p>
         </p:txBody>
       </p:sp>
@@ -3609,8 +3609,8 @@
         </p:nvSpPr>
         <p:spPr>
           <a:xfrm>
-            <a:off x="5989320" y="3895344"/>
-            <a:ext cx="5650992" cy="777240"/>
+            <a:off x="5989320" y="3931920"/>
+            <a:ext cx="5650992" cy="685800"/>
           </a:xfrm>
           <a:prstGeom prst="rect">
             <a:avLst/>
@@ -3626,7 +3626,7 @@
               <a:buNone/>
             </a:pPr>
             <a:r>
-              <a:rPr lang="en-US" sz="1050" dirty="0">
+              <a:rPr lang="en-US" sz="1150" dirty="0">
                 <a:solidFill>
                   <a:srgbClr val="6B7280"/>
                 </a:solidFill>
@@ -3634,9 +3634,9 @@
                 <a:ea typeface="Calibri" pitchFamily="34" charset="-122"/>
                 <a:cs typeface="Calibri" pitchFamily="34" charset="-120"/>
               </a:rPr>
-              <a:t>build_synthesis_capsule() prefers the Matrix's four fields, falling back to the abstract or extracted text.</a:t>
-            </a:r>
-            <a:endParaRPr lang="en-US" sz="1050" dirty="0"/>
+              <a:t>Choose two or more papers you've already saved to the project.</a:t>
+            </a:r>
+            <a:endParaRPr lang="en-US" sz="1150" dirty="0"/>
           </a:p>
         </p:txBody>
       </p:sp>
@@ -3724,7 +3724,7 @@
               <a:buNone/>
             </a:pPr>
             <a:r>
-              <a:rPr lang="en-US" sz="1200" b="1" dirty="0">
+              <a:rPr lang="en-US" sz="1300" b="1" dirty="0">
                 <a:solidFill>
                   <a:srgbClr val="1E1B4B"/>
                 </a:solidFill>
@@ -3732,9 +3732,9 @@
                 <a:ea typeface="Calibri" pitchFamily="34" charset="-122"/>
                 <a:cs typeface="Calibri" pitchFamily="34" charset="-120"/>
               </a:rPr>
-              <a:t>Streamed like a chat reply</a:t>
-            </a:r>
-            <a:endParaRPr lang="en-US" sz="1200" dirty="0"/>
+              <a:t>AI writes one combined write-up</a:t>
+            </a:r>
+            <a:endParaRPr lang="en-US" sz="1300" dirty="0"/>
           </a:p>
         </p:txBody>
       </p:sp>
@@ -3746,8 +3746,8 @@
         </p:nvSpPr>
         <p:spPr>
           <a:xfrm>
-            <a:off x="5989320" y="4919472"/>
-            <a:ext cx="5650992" cy="777240"/>
+            <a:off x="5989320" y="4956048"/>
+            <a:ext cx="5650992" cy="685800"/>
           </a:xfrm>
           <a:prstGeom prst="rect">
             <a:avLst/>
@@ -3763,7 +3763,7 @@
               <a:buNone/>
             </a:pPr>
             <a:r>
-              <a:rPr lang="en-US" sz="1050" dirty="0">
+              <a:rPr lang="en-US" sz="1150" dirty="0">
                 <a:solidFill>
                   <a:srgbClr val="6B7280"/>
                 </a:solidFill>
@@ -3771,9 +3771,9 @@
                 <a:ea typeface="Calibri" pitchFamily="34" charset="-122"/>
                 <a:cs typeface="Calibri" pitchFamily="34" charset="-120"/>
               </a:rPr>
-              <a:t>Checked paper_ids are re-validated server-side, then streamed live as NDJSON, token by token.</a:t>
-            </a:r>
-            <a:endParaRPr lang="en-US" sz="1050" dirty="0"/>
+              <a:t>Instead of six separate summaries, you get one piece of writing that connects and compares them.</a:t>
+            </a:r>
+            <a:endParaRPr lang="en-US" sz="1150" dirty="0"/>
           </a:p>
         </p:txBody>
       </p:sp>
@@ -3861,7 +3861,7 @@
               <a:buNone/>
             </a:pPr>
             <a:r>
-              <a:rPr lang="en-US" sz="1200" b="1" dirty="0">
+              <a:rPr lang="en-US" sz="1300" b="1" dirty="0">
                 <a:solidFill>
                   <a:srgbClr val="1E1B4B"/>
                 </a:solidFill>
@@ -3869,9 +3869,9 @@
                 <a:ea typeface="Calibri" pitchFamily="34" charset="-122"/>
                 <a:cs typeface="Calibri" pitchFamily="34" charset="-120"/>
               </a:rPr>
-              <a:t>Saved with its own sources</a:t>
-            </a:r>
-            <a:endParaRPr lang="en-US" sz="1200" dirty="0"/>
+              <a:t>Know exactly what it's based on</a:t>
+            </a:r>
+            <a:endParaRPr lang="en-US" sz="1300" dirty="0"/>
           </a:p>
         </p:txBody>
       </p:sp>
@@ -3883,8 +3883,8 @@
         </p:nvSpPr>
         <p:spPr>
           <a:xfrm>
-            <a:off x="5989320" y="5943600"/>
-            <a:ext cx="5650992" cy="777240"/>
+            <a:off x="5989320" y="5980176"/>
+            <a:ext cx="5650992" cy="685800"/>
           </a:xfrm>
           <a:prstGeom prst="rect">
             <a:avLst/>
@@ -3900,7 +3900,7 @@
               <a:buNone/>
             </a:pPr>
             <a:r>
-              <a:rPr lang="en-US" sz="1050" dirty="0">
+              <a:rPr lang="en-US" sz="1150" dirty="0">
                 <a:solidFill>
                   <a:srgbClr val="6B7280"/>
                 </a:solidFill>
@@ -3908,9 +3908,9 @@
                 <a:ea typeface="Calibri" pitchFamily="34" charset="-122"/>
                 <a:cs typeface="Calibri" pitchFamily="34" charset="-120"/>
               </a:rPr>
-              <a:t>The exact source paper_ids are stored alongside the text, so “Based on: …” stays accurate after a reload.</a:t>
-            </a:r>
-            <a:endParaRPr lang="en-US" sz="1050" dirty="0"/>
+              <a:t>The result always shows which papers it used, so you can double check.</a:t>
+            </a:r>
+            <a:endParaRPr lang="en-US" sz="1150" dirty="0"/>
           </a:p>
         </p:txBody>
       </p:sp>
@@ -4329,7 +4329,7 @@
               <a:buNone/>
             </a:pPr>
             <a:r>
-              <a:rPr lang="en-US" sz="1200" b="1" dirty="0">
+              <a:rPr lang="en-US" sz="1300" b="1" dirty="0">
                 <a:solidFill>
                   <a:srgbClr val="1E1B4B"/>
                 </a:solidFill>
@@ -4337,9 +4337,9 @@
                 <a:ea typeface="Calibri" pitchFamily="34" charset="-122"/>
                 <a:cs typeface="Calibri" pitchFamily="34" charset="-120"/>
               </a:rPr>
-              <a:t>History is capped, not unbounded</a:t>
-            </a:r>
-            <a:endParaRPr lang="en-US" sz="1200" dirty="0"/>
+              <a:t>Ask in your own words</a:t>
+            </a:r>
+            <a:endParaRPr lang="en-US" sz="1300" dirty="0"/>
           </a:p>
         </p:txBody>
       </p:sp>
@@ -4351,8 +4351,8 @@
         </p:nvSpPr>
         <p:spPr>
           <a:xfrm>
-            <a:off x="6812280" y="3895344"/>
-            <a:ext cx="4828032" cy="777240"/>
+            <a:off x="6812280" y="3931920"/>
+            <a:ext cx="4828032" cy="685800"/>
           </a:xfrm>
           <a:prstGeom prst="rect">
             <a:avLst/>
@@ -4368,7 +4368,7 @@
               <a:buNone/>
             </a:pPr>
             <a:r>
-              <a:rPr lang="en-US" sz="1050" dirty="0">
+              <a:rPr lang="en-US" sz="1150" dirty="0">
                 <a:solidFill>
                   <a:srgbClr val="6B7280"/>
                 </a:solidFill>
@@ -4376,9 +4376,9 @@
                 <a:ea typeface="Calibri" pitchFamily="34" charset="-122"/>
                 <a:cs typeface="Calibri" pitchFamily="34" charset="-120"/>
               </a:rPr>
-              <a:t>Only the last 8 turns are resent to the model; full history still lives in the database and on the page.</a:t>
-            </a:r>
-            <a:endParaRPr lang="en-US" sz="1050" dirty="0"/>
+              <a:t>Type a question about your saved papers, just like texting a research assistant.</a:t>
+            </a:r>
+            <a:endParaRPr lang="en-US" sz="1150" dirty="0"/>
           </a:p>
         </p:txBody>
       </p:sp>
@@ -4466,7 +4466,7 @@
               <a:buNone/>
             </a:pPr>
             <a:r>
-              <a:rPr lang="en-US" sz="1200" b="1" dirty="0">
+              <a:rPr lang="en-US" sz="1300" b="1" dirty="0">
                 <a:solidFill>
                   <a:srgbClr val="1E1B4B"/>
                 </a:solidFill>
@@ -4474,9 +4474,9 @@
                 <a:ea typeface="Calibri" pitchFamily="34" charset="-122"/>
                 <a:cs typeface="Calibri" pitchFamily="34" charset="-120"/>
               </a:rPr>
-              <a:t>Per-piece prompt budgets</a:t>
-            </a:r>
-            <a:endParaRPr lang="en-US" sz="1200" dirty="0"/>
+              <a:t>It reads everything you've saved</a:t>
+            </a:r>
+            <a:endParaRPr lang="en-US" sz="1300" dirty="0"/>
           </a:p>
         </p:txBody>
       </p:sp>
@@ -4488,8 +4488,8 @@
         </p:nvSpPr>
         <p:spPr>
           <a:xfrm>
-            <a:off x="6812280" y="4919472"/>
-            <a:ext cx="4828032" cy="777240"/>
+            <a:off x="6812280" y="4956048"/>
+            <a:ext cx="4828032" cy="685800"/>
           </a:xfrm>
           <a:prstGeom prst="rect">
             <a:avLst/>
@@ -4505,7 +4505,7 @@
               <a:buNone/>
             </a:pPr>
             <a:r>
-              <a:rPr lang="en-US" sz="1050" dirty="0">
+              <a:rPr lang="en-US" sz="1150" dirty="0">
                 <a:solidFill>
                   <a:srgbClr val="6B7280"/>
                 </a:solidFill>
@@ -4513,9 +4513,9 @@
                 <a:ea typeface="Calibri" pitchFamily="34" charset="-122"/>
                 <a:cs typeface="Calibri" pitchFamily="34" charset="-120"/>
               </a:rPr>
-              <a:t>Papers / history / question are each capped before assembly, so the newest question can never be truncated away.</a:t>
-            </a:r>
-            <a:endParaRPr lang="en-US" sz="1050" dirty="0"/>
+              <a:t>The answer draws on every paper in the project, not just one or two.</a:t>
+            </a:r>
+            <a:endParaRPr lang="en-US" sz="1150" dirty="0"/>
           </a:p>
         </p:txBody>
       </p:sp>
@@ -4603,7 +4603,7 @@
               <a:buNone/>
             </a:pPr>
             <a:r>
-              <a:rPr lang="en-US" sz="1200" b="1" dirty="0">
+              <a:rPr lang="en-US" sz="1300" b="1" dirty="0">
                 <a:solidFill>
                   <a:srgbClr val="1E1B4B"/>
                 </a:solidFill>
@@ -4611,9 +4611,9 @@
                 <a:ea typeface="Calibri" pitchFamily="34" charset="-122"/>
                 <a:cs typeface="Calibri" pitchFamily="34" charset="-120"/>
               </a:rPr>
-              <a:t>Edit + Resend truncates forward</a:t>
-            </a:r>
-            <a:endParaRPr lang="en-US" sz="1200" dirty="0"/>
+              <a:t>Keep the conversation going</a:t>
+            </a:r>
+            <a:endParaRPr lang="en-US" sz="1300" dirty="0"/>
           </a:p>
         </p:txBody>
       </p:sp>
@@ -4625,8 +4625,8 @@
         </p:nvSpPr>
         <p:spPr>
           <a:xfrm>
-            <a:off x="6812280" y="5943600"/>
-            <a:ext cx="4828032" cy="777240"/>
+            <a:off x="6812280" y="5980176"/>
+            <a:ext cx="4828032" cy="685800"/>
           </a:xfrm>
           <a:prstGeom prst="rect">
             <a:avLst/>
@@ -4642,7 +4642,7 @@
               <a:buNone/>
             </a:pPr>
             <a:r>
-              <a:rPr lang="en-US" sz="1050" dirty="0">
+              <a:rPr lang="en-US" sz="1150" dirty="0">
                 <a:solidFill>
                   <a:srgbClr val="6B7280"/>
                 </a:solidFill>
@@ -4650,9 +4650,9 @@
                 <a:ea typeface="Calibri" pitchFamily="34" charset="-122"/>
                 <a:cs typeface="Calibri" pitchFamily="34" charset="-120"/>
               </a:rPr>
-              <a:t>Editing a question deletes everything after it — one linear thread, never a branching one.</a:t>
-            </a:r>
-            <a:endParaRPr lang="en-US" sz="1050" dirty="0"/>
+              <a:t>Ask follow-up questions, or edit an earlier one to get a fresh answer.</a:t>
+            </a:r>
+            <a:endParaRPr lang="en-US" sz="1150" dirty="0"/>
           </a:p>
         </p:txBody>
       </p:sp>
@@ -5383,7 +5383,7 @@
                 <a:ea typeface="Calibri" pitchFamily="34" charset="-122"/>
                 <a:cs typeface="Calibri" pitchFamily="34" charset="-120"/>
               </a:rPr>
-              <a:t>Test authentication, academic search, and AI analysis — including the OpenAI Agent — end to end</a:t>
+              <a:t>Test authentication, academic search, and AI analysis end to end</a:t>
             </a:r>
             <a:endParaRPr lang="en-US" sz="1100" dirty="0"/>
           </a:p>

</xml_diff>